<commit_message>
Close up the transpose in lesson 3's by-hand table
XᵀX was written with a space in four places while the equation two slides
earlier sets it closed up, and the Xᵀy row carried a stray space before
its comma.

Co-Authored-By: Claude Opus 5 <noreply@anthropic.com>
Claude-Session: https://claude.ai/code/session_01RUgbrkGymrGY6d6KXvKkff
</commit_message>
<xml_diff>
--- a/Lessons/03_regression/Slides/regression_slides.pptx
+++ b/Lessons/03_regression/Slides/regression_slides.pptx
@@ -1320,7 +1320,7 @@
             </a:pPr>
             <a:r>
               <a:rPr/>
-              <a:t>Here it does, because the cost is convex. Give the one-line reason without the algebra: Xᵀ X can never be negative in any direction, since asking for its value in direction v gives the squared length of Xv, and a squared length is never negative.</a:t>
+              <a:t>Here it does, because the cost is convex. Give the one-line reason without the algebra: XᵀX can never be negative in any direction, since asking for its value in direction v gives the squared length of Xv, and a squared length is never negative.</a:t>
             </a:r>
           </a:p>
           <a:p>
@@ -10549,7 +10549,7 @@
                       </a:pPr>
                       <a:r>
                         <a:rPr/>
-                        <a:t>Xᵀ X</a:t>
+                        <a:t>XᵀX</a:t>
                       </a:r>
                     </a:p>
                   </a:txBody>
@@ -10581,7 +10581,7 @@
                       </a:pPr>
                       <a:r>
                         <a:rPr/>
-                        <a:t>Xᵀ y</a:t>
+                        <a:t>Xᵀy</a:t>
                       </a:r>
                     </a:p>
                   </a:txBody>
@@ -10596,7 +10596,7 @@
                       </a:pPr>
                       <a:r>
                         <a:rPr/>
-                        <a:t>(1,100 , 165,600)</a:t>
+                        <a:t>(1,100, 165,600)</a:t>
                       </a:r>
                     </a:p>
                   </a:txBody>
@@ -10781,7 +10781,7 @@
             <a:pPr lvl="0"/>
             <a:r>
               <a:rPr/>
-              <a:t>The second derivative is Xᵀ X, never negative in any direction</a:t>
+              <a:t>The second derivative is XᵀX, never negative in any direction</a:t>
             </a:r>
           </a:p>
           <a:p>

</xml_diff>